<commit_message>
Actualizacion de documentos e inclusion de captura docker
</commit_message>
<xml_diff>
--- a/exposicion/presentacion.pptx
+++ b/exposicion/presentacion.pptx
@@ -2,24 +2,24 @@
 <file path=ppt/presentation.xml><?xml version="1.0" encoding="utf-8"?>
 <p:presentation xmlns:p="http://schemas.openxmlformats.org/presentationml/2006/main">
   <p:sldMasterIdLst>
-    <p:sldMasterId xmlns:r="http://schemas.openxmlformats.org/officeDocument/2006/relationships" id="2147483648" r:id="R6beb22bc2e294786"/>
+    <p:sldMasterId xmlns:r="http://schemas.openxmlformats.org/officeDocument/2006/relationships" id="2147483648" r:id="R0895f6765efe4118"/>
   </p:sldMasterIdLst>
   <p:notesMasterIdLst>
-    <p:notesMasterId xmlns:r="http://schemas.openxmlformats.org/officeDocument/2006/relationships" r:id="Ra87101cb85a64507"/>
+    <p:notesMasterId xmlns:r="http://schemas.openxmlformats.org/officeDocument/2006/relationships" r:id="Rc1d2ab7151ea4018"/>
   </p:notesMasterIdLst>
   <p:sldIdLst>
-    <p:sldId xmlns:r="http://schemas.openxmlformats.org/officeDocument/2006/relationships" id="256" r:id="Rac7713136c3546df"/>
-    <p:sldId xmlns:r="http://schemas.openxmlformats.org/officeDocument/2006/relationships" id="257" r:id="R9285a227e3d94258"/>
-    <p:sldId xmlns:r="http://schemas.openxmlformats.org/officeDocument/2006/relationships" id="258" r:id="R9420e4b215f14f71"/>
-    <p:sldId xmlns:r="http://schemas.openxmlformats.org/officeDocument/2006/relationships" id="259" r:id="Rb24ef35b68ca4b5e"/>
-    <p:sldId xmlns:r="http://schemas.openxmlformats.org/officeDocument/2006/relationships" id="260" r:id="R4d02bfe421534c42"/>
-    <p:sldId xmlns:r="http://schemas.openxmlformats.org/officeDocument/2006/relationships" id="261" r:id="R7c3d4459975f431c"/>
-    <p:sldId xmlns:r="http://schemas.openxmlformats.org/officeDocument/2006/relationships" id="262" r:id="Rf8112fa532774068"/>
-    <p:sldId xmlns:r="http://schemas.openxmlformats.org/officeDocument/2006/relationships" id="263" r:id="R42904302af664d30"/>
-    <p:sldId xmlns:r="http://schemas.openxmlformats.org/officeDocument/2006/relationships" id="264" r:id="Re1f8af7b4a734966"/>
-    <p:sldId xmlns:r="http://schemas.openxmlformats.org/officeDocument/2006/relationships" id="265" r:id="Rd7f3410899e44399"/>
-    <p:sldId xmlns:r="http://schemas.openxmlformats.org/officeDocument/2006/relationships" id="266" r:id="R6aab5ff744a942e9"/>
-    <p:sldId xmlns:r="http://schemas.openxmlformats.org/officeDocument/2006/relationships" id="267" r:id="R1c77bfb1abca4d90"/>
+    <p:sldId xmlns:r="http://schemas.openxmlformats.org/officeDocument/2006/relationships" id="256" r:id="R7df037ef438a4486"/>
+    <p:sldId xmlns:r="http://schemas.openxmlformats.org/officeDocument/2006/relationships" id="257" r:id="Rd0309b987d7c47fa"/>
+    <p:sldId xmlns:r="http://schemas.openxmlformats.org/officeDocument/2006/relationships" id="258" r:id="Rf2bae8a0bb4f4bd8"/>
+    <p:sldId xmlns:r="http://schemas.openxmlformats.org/officeDocument/2006/relationships" id="259" r:id="R76257605fea4460a"/>
+    <p:sldId xmlns:r="http://schemas.openxmlformats.org/officeDocument/2006/relationships" id="260" r:id="R391969b160a649e5"/>
+    <p:sldId xmlns:r="http://schemas.openxmlformats.org/officeDocument/2006/relationships" id="261" r:id="R840bb0303c46424b"/>
+    <p:sldId xmlns:r="http://schemas.openxmlformats.org/officeDocument/2006/relationships" id="262" r:id="Ra3e546669a92480d"/>
+    <p:sldId xmlns:r="http://schemas.openxmlformats.org/officeDocument/2006/relationships" id="263" r:id="Re62b7695d4f94ea1"/>
+    <p:sldId xmlns:r="http://schemas.openxmlformats.org/officeDocument/2006/relationships" id="264" r:id="Redbac85c4394444f"/>
+    <p:sldId xmlns:r="http://schemas.openxmlformats.org/officeDocument/2006/relationships" id="265" r:id="Rfe2ddb72035941e4"/>
+    <p:sldId xmlns:r="http://schemas.openxmlformats.org/officeDocument/2006/relationships" id="266" r:id="R41456706195a45d2"/>
+    <p:sldId xmlns:r="http://schemas.openxmlformats.org/officeDocument/2006/relationships" id="267" r:id="R87bbabde58eb4f75"/>
   </p:sldIdLst>
   <p:sldSz cx="9144000" cy="5143500"/>
   <p:notesSz cx="6858000" cy="9144000"/>
@@ -1163,7 +1163,7 @@
           <a:lstStyle xmlns:a="http://schemas.openxmlformats.org/drawingml/2006/main"/>
           <a:p xmlns:a="http://schemas.openxmlformats.org/drawingml/2006/main">
             <a:r>
-              <a:t>Captura real del 18/10/2026. El filtro pasó de 21 eventos con magnitud mínima 5 a 3 con magnitud mínima 6. La base respondió con 319592 filas en dim_sismos. Comandos reales en capturas/ejecucion-2026-10-18.txt. Sigue pendiente una captura auténtica del arranque en terminal. Los indicadores de población son resultados de la aplicación y no equivalen a personas damnificadas observadas.</a:t>
+              <a:t>Captura real del 18/10/2026. El filtro pasó de 21 eventos con magnitud mínima 5 a 3 con magnitud mínima 6. La base respondió con 319592 filas en dim_sismos. Comandos reales en capturas/ejecucion-2026-10-18.txt. La captura auténtica de PowerShell está en capturas/arranque-terminal-2026-10-18.png. Los indicadores de población son resultados de la aplicación y no equivalen a personas damnificadas observadas.</a:t>
             </a:r>
           </a:p>
         </p:txBody>
@@ -1710,7 +1710,7 @@
           <p:cNvPr id="3" name="Title">
             <a:extLst xmlns:a="http://schemas.openxmlformats.org/drawingml/2006/main">
               <a:ext uri="{FF2B5EF4-FFF2-40B4-BE49-F238E27FC236}">
-                <a16:creationId xmlns:a16="http://schemas.microsoft.com/office/drawing/2014/main" id="{2F281403-FA55-495B-AE56-F3257FF2938C}"/>
+                <a16:creationId xmlns:a16="http://schemas.microsoft.com/office/drawing/2014/main" id="{5643C6EF-3BB1-4F00-989A-80B5FDED0992}"/>
               </a:ext>
             </a:extLst>
           </p:cNvPr>
@@ -1939,7 +1939,7 @@
           <p:cNvPr id="2" name="Subtitle">
             <a:extLst xmlns:a="http://schemas.openxmlformats.org/drawingml/2006/main">
               <a:ext uri="{FF2B5EF4-FFF2-40B4-BE49-F238E27FC236}">
-                <a16:creationId xmlns:a16="http://schemas.microsoft.com/office/drawing/2014/main" id="{FC5EE7E1-CF61-47A0-B2BD-B6BA21CE24A4}"/>
+                <a16:creationId xmlns:a16="http://schemas.microsoft.com/office/drawing/2014/main" id="{0DF69843-FBFE-4C78-9A4F-2041313FEA5C}"/>
               </a:ext>
             </a:extLst>
           </p:cNvPr>
@@ -2185,7 +2185,7 @@
           <p:cNvPr id="2" name="Section title">
             <a:extLst xmlns:a="http://schemas.openxmlformats.org/drawingml/2006/main">
               <a:ext uri="{FF2B5EF4-FFF2-40B4-BE49-F238E27FC236}">
-                <a16:creationId xmlns:a16="http://schemas.microsoft.com/office/drawing/2014/main" id="{C481DECD-777C-4FA6-85A4-0AF7FD0D9B8D}"/>
+                <a16:creationId xmlns:a16="http://schemas.microsoft.com/office/drawing/2014/main" id="{78220ABC-5766-4637-9936-5E3B80BF1F36}"/>
               </a:ext>
             </a:extLst>
           </p:cNvPr>
@@ -2431,7 +2431,7 @@
           <p:cNvPr id="3" name="Title">
             <a:extLst xmlns:a="http://schemas.openxmlformats.org/drawingml/2006/main">
               <a:ext uri="{FF2B5EF4-FFF2-40B4-BE49-F238E27FC236}">
-                <a16:creationId xmlns:a16="http://schemas.microsoft.com/office/drawing/2014/main" id="{3CA8C214-B194-4A78-97C4-D844B3424AE6}"/>
+                <a16:creationId xmlns:a16="http://schemas.microsoft.com/office/drawing/2014/main" id="{2FACF38B-116E-4EAA-83E3-A5F126CFE1D4}"/>
               </a:ext>
             </a:extLst>
           </p:cNvPr>
@@ -2660,7 +2660,7 @@
           <p:cNvPr id="2" name="Body">
             <a:extLst xmlns:a="http://schemas.openxmlformats.org/drawingml/2006/main">
               <a:ext uri="{FF2B5EF4-FFF2-40B4-BE49-F238E27FC236}">
-                <a16:creationId xmlns:a16="http://schemas.microsoft.com/office/drawing/2014/main" id="{6D02B2B4-F23E-409B-8A75-3A1B8FB2E88D}"/>
+                <a16:creationId xmlns:a16="http://schemas.microsoft.com/office/drawing/2014/main" id="{5212935E-8152-4F3E-BE3D-DDA715D63A9C}"/>
               </a:ext>
             </a:extLst>
           </p:cNvPr>
@@ -2906,7 +2906,7 @@
           <p:cNvPr id="4" name="Title">
             <a:extLst xmlns:a="http://schemas.openxmlformats.org/drawingml/2006/main">
               <a:ext uri="{FF2B5EF4-FFF2-40B4-BE49-F238E27FC236}">
-                <a16:creationId xmlns:a16="http://schemas.microsoft.com/office/drawing/2014/main" id="{69A60341-FBD1-4745-B2FC-2657C24FF71F}"/>
+                <a16:creationId xmlns:a16="http://schemas.microsoft.com/office/drawing/2014/main" id="{BE79ADDD-568A-4CCC-900E-7102A55139F9}"/>
               </a:ext>
             </a:extLst>
           </p:cNvPr>
@@ -3135,7 +3135,7 @@
           <p:cNvPr id="2" name="Left column">
             <a:extLst xmlns:a="http://schemas.openxmlformats.org/drawingml/2006/main">
               <a:ext uri="{FF2B5EF4-FFF2-40B4-BE49-F238E27FC236}">
-                <a16:creationId xmlns:a16="http://schemas.microsoft.com/office/drawing/2014/main" id="{354A4EB5-4D37-431E-9BFF-E1C9EEFC82CF}"/>
+                <a16:creationId xmlns:a16="http://schemas.microsoft.com/office/drawing/2014/main" id="{0F5416C4-0109-442B-8399-8E387EAF464B}"/>
               </a:ext>
             </a:extLst>
           </p:cNvPr>
@@ -3364,7 +3364,7 @@
           <p:cNvPr id="3" name="Right column">
             <a:extLst xmlns:a="http://schemas.openxmlformats.org/drawingml/2006/main">
               <a:ext uri="{FF2B5EF4-FFF2-40B4-BE49-F238E27FC236}">
-                <a16:creationId xmlns:a16="http://schemas.microsoft.com/office/drawing/2014/main" id="{26265904-A39C-42A4-AF4D-91C1654C6712}"/>
+                <a16:creationId xmlns:a16="http://schemas.microsoft.com/office/drawing/2014/main" id="{E51F4E7D-0CC8-4A4A-9A26-49C01BAACFA7}"/>
               </a:ext>
             </a:extLst>
           </p:cNvPr>
@@ -3610,7 +3610,7 @@
           <p:cNvPr id="3" name="Title">
             <a:extLst xmlns:a="http://schemas.openxmlformats.org/drawingml/2006/main">
               <a:ext uri="{FF2B5EF4-FFF2-40B4-BE49-F238E27FC236}">
-                <a16:creationId xmlns:a16="http://schemas.microsoft.com/office/drawing/2014/main" id="{40C99027-2D36-43C6-89D9-16C62384B2E4}"/>
+                <a16:creationId xmlns:a16="http://schemas.microsoft.com/office/drawing/2014/main" id="{9BCD321C-8116-45A1-87A0-AF1F41A7951B}"/>
               </a:ext>
             </a:extLst>
           </p:cNvPr>
@@ -3839,7 +3839,7 @@
           <p:cNvPr id="2" name="Left column">
             <a:extLst xmlns:a="http://schemas.openxmlformats.org/drawingml/2006/main">
               <a:ext uri="{FF2B5EF4-FFF2-40B4-BE49-F238E27FC236}">
-                <a16:creationId xmlns:a16="http://schemas.microsoft.com/office/drawing/2014/main" id="{102C85C8-8E34-4EF2-A86E-996BCD929777}"/>
+                <a16:creationId xmlns:a16="http://schemas.microsoft.com/office/drawing/2014/main" id="{FC61158E-7808-4168-9E20-CDB143295BF2}"/>
               </a:ext>
             </a:extLst>
           </p:cNvPr>
@@ -4106,12 +4106,12 @@
   </p:cSld>
   <p:clrMap bg1="lt1" tx1="dk1" bg2="lt2" tx2="dk2" accent1="accent1" accent2="accent2" accent3="accent3" accent4="accent4" accent5="accent5" accent6="accent6" hlink="hlink" folHlink="folHlink"/>
   <p:sldLayoutIdLst>
-    <p:sldLayoutId xmlns:r="http://schemas.openxmlformats.org/officeDocument/2006/relationships" id="2147483649" r:id="R90d4fad17d2a4f06"/>
-    <p:sldLayoutId xmlns:r="http://schemas.openxmlformats.org/officeDocument/2006/relationships" id="2147483650" r:id="Rbf8bab4571dd45d8"/>
-    <p:sldLayoutId xmlns:r="http://schemas.openxmlformats.org/officeDocument/2006/relationships" id="2147483651" r:id="R4bfd3fb293af4723"/>
-    <p:sldLayoutId xmlns:r="http://schemas.openxmlformats.org/officeDocument/2006/relationships" id="2147483652" r:id="R4176b56f38284f11"/>
-    <p:sldLayoutId xmlns:r="http://schemas.openxmlformats.org/officeDocument/2006/relationships" id="2147483653" r:id="Ra71c13d167774d12"/>
-    <p:sldLayoutId xmlns:r="http://schemas.openxmlformats.org/officeDocument/2006/relationships" id="2147483654" r:id="R9534847b6d8a4121"/>
+    <p:sldLayoutId xmlns:r="http://schemas.openxmlformats.org/officeDocument/2006/relationships" id="2147483649" r:id="R5e4d8dc22f464f45"/>
+    <p:sldLayoutId xmlns:r="http://schemas.openxmlformats.org/officeDocument/2006/relationships" id="2147483650" r:id="R23262c351e9a4314"/>
+    <p:sldLayoutId xmlns:r="http://schemas.openxmlformats.org/officeDocument/2006/relationships" id="2147483651" r:id="Raf589dd8e35b4289"/>
+    <p:sldLayoutId xmlns:r="http://schemas.openxmlformats.org/officeDocument/2006/relationships" id="2147483652" r:id="Rf5265a9ac9014f04"/>
+    <p:sldLayoutId xmlns:r="http://schemas.openxmlformats.org/officeDocument/2006/relationships" id="2147483653" r:id="R440fdebb71fd4ebe"/>
+    <p:sldLayoutId xmlns:r="http://schemas.openxmlformats.org/officeDocument/2006/relationships" id="2147483654" r:id="R294c1d3216bf41b4"/>
   </p:sldLayoutIdLst>
   <p:txStyles>
     <p:titleStyle>
@@ -4662,7 +4662,7 @@
           <p:cNvPr id="8" name="">
             <a:extLst xmlns:a="http://schemas.openxmlformats.org/drawingml/2006/main">
               <a:ext uri="{FF2B5EF4-FFF2-40B4-BE49-F238E27FC236}">
-                <a16:creationId xmlns:a16="http://schemas.microsoft.com/office/drawing/2014/main" id="{E8AB5BF9-7AB1-4844-A870-FEB3F9CB7CF7}"/>
+                <a16:creationId xmlns:a16="http://schemas.microsoft.com/office/drawing/2014/main" id="{80A952CD-D038-4D01-A6CD-1CD1EDBC7836}"/>
               </a:ext>
             </a:extLst>
           </p:cNvPr>
@@ -4819,7 +4819,7 @@
           <p:cNvPr id="2" name="">
             <a:extLst xmlns:a="http://schemas.openxmlformats.org/drawingml/2006/main">
               <a:ext uri="{FF2B5EF4-FFF2-40B4-BE49-F238E27FC236}">
-                <a16:creationId xmlns:a16="http://schemas.microsoft.com/office/drawing/2014/main" id="{23AB265A-5529-4AFD-B41B-844C9DCEFA7B}"/>
+                <a16:creationId xmlns:a16="http://schemas.microsoft.com/office/drawing/2014/main" id="{5C1A2644-7646-4E03-A14E-5C27F3ED2F20}"/>
               </a:ext>
             </a:extLst>
           </p:cNvPr>
@@ -4976,7 +4976,7 @@
           <p:cNvPr id="3" name="">
             <a:extLst xmlns:a="http://schemas.openxmlformats.org/drawingml/2006/main">
               <a:ext uri="{FF2B5EF4-FFF2-40B4-BE49-F238E27FC236}">
-                <a16:creationId xmlns:a16="http://schemas.microsoft.com/office/drawing/2014/main" id="{A1FA52B8-C500-46FA-87D3-255C233969AE}"/>
+                <a16:creationId xmlns:a16="http://schemas.microsoft.com/office/drawing/2014/main" id="{48FB9855-30C7-4627-804C-19385B6CFD88}"/>
               </a:ext>
             </a:extLst>
           </p:cNvPr>
@@ -5133,7 +5133,7 @@
           <p:cNvPr id="4" name="">
             <a:extLst xmlns:a="http://schemas.openxmlformats.org/drawingml/2006/main">
               <a:ext uri="{FF2B5EF4-FFF2-40B4-BE49-F238E27FC236}">
-                <a16:creationId xmlns:a16="http://schemas.microsoft.com/office/drawing/2014/main" id="{07534371-17FB-45E7-8D4B-077EDF3D5B9E}"/>
+                <a16:creationId xmlns:a16="http://schemas.microsoft.com/office/drawing/2014/main" id="{3EC51FAD-7D99-443A-A3B0-84399F1D1303}"/>
               </a:ext>
             </a:extLst>
           </p:cNvPr>
@@ -5290,7 +5290,7 @@
           <p:cNvPr id="5" name="">
             <a:extLst xmlns:a="http://schemas.openxmlformats.org/drawingml/2006/main">
               <a:ext uri="{FF2B5EF4-FFF2-40B4-BE49-F238E27FC236}">
-                <a16:creationId xmlns:a16="http://schemas.microsoft.com/office/drawing/2014/main" id="{D77CA480-102D-4B84-8B48-B55627AF3B2F}"/>
+                <a16:creationId xmlns:a16="http://schemas.microsoft.com/office/drawing/2014/main" id="{83EDC30E-76FB-4EE4-BBF5-0B2573B4C7E8}"/>
               </a:ext>
             </a:extLst>
           </p:cNvPr>
@@ -5447,7 +5447,7 @@
           <p:cNvPr id="6" name="">
             <a:extLst xmlns:a="http://schemas.openxmlformats.org/drawingml/2006/main">
               <a:ext uri="{FF2B5EF4-FFF2-40B4-BE49-F238E27FC236}">
-                <a16:creationId xmlns:a16="http://schemas.microsoft.com/office/drawing/2014/main" id="{1D97BC74-291C-40CE-AFD0-057886452428}"/>
+                <a16:creationId xmlns:a16="http://schemas.microsoft.com/office/drawing/2014/main" id="{72E6B886-D467-4EAD-AA9E-99A488FA36E8}"/>
               </a:ext>
             </a:extLst>
           </p:cNvPr>
@@ -5673,7 +5673,7 @@
           <p:cNvPr id="7" name="">
             <a:extLst xmlns:a="http://schemas.openxmlformats.org/drawingml/2006/main">
               <a:ext uri="{FF2B5EF4-FFF2-40B4-BE49-F238E27FC236}">
-                <a16:creationId xmlns:a16="http://schemas.microsoft.com/office/drawing/2014/main" id="{CBB7CF41-0681-4223-BD81-BDA647D61B19}"/>
+                <a16:creationId xmlns:a16="http://schemas.microsoft.com/office/drawing/2014/main" id="{A4D94243-8A79-4562-A8BC-75DAC34F49D1}"/>
               </a:ext>
             </a:extLst>
           </p:cNvPr>
@@ -5828,7 +5828,7 @@
     </p:spTree>
     <p:extLst>
       <p:ext uri="{BB962C8B-B14F-4D97-AF65-F5344CB8AC3E}">
-        <p14:creationId xmlns:p14="http://schemas.microsoft.com/office/powerpoint/2010/main" val="1658412144"/>
+        <p14:creationId xmlns:p14="http://schemas.microsoft.com/office/powerpoint/2010/main" val="991102310"/>
       </p:ext>
     </p:extLst>
   </p:cSld>
@@ -5859,7 +5859,7 @@
           <p:cNvPr id="12" name="">
             <a:extLst xmlns:a="http://schemas.openxmlformats.org/drawingml/2006/main">
               <a:ext uri="{FF2B5EF4-FFF2-40B4-BE49-F238E27FC236}">
-                <a16:creationId xmlns:a16="http://schemas.microsoft.com/office/drawing/2014/main" id="{38EAD472-9E5F-4D09-9E5B-E323D9AF238D}"/>
+                <a16:creationId xmlns:a16="http://schemas.microsoft.com/office/drawing/2014/main" id="{FC1674E6-25D5-4E98-A091-4F334B1B501A}"/>
               </a:ext>
             </a:extLst>
           </p:cNvPr>
@@ -6016,7 +6016,7 @@
           <p:cNvPr id="2" name="">
             <a:extLst xmlns:a="http://schemas.openxmlformats.org/drawingml/2006/main">
               <a:ext uri="{FF2B5EF4-FFF2-40B4-BE49-F238E27FC236}">
-                <a16:creationId xmlns:a16="http://schemas.microsoft.com/office/drawing/2014/main" id="{96DAC909-916E-4327-AD82-8A6864E4C471}"/>
+                <a16:creationId xmlns:a16="http://schemas.microsoft.com/office/drawing/2014/main" id="{6ACC553A-A488-413D-8CB4-D677B706E57C}"/>
               </a:ext>
             </a:extLst>
           </p:cNvPr>
@@ -6173,7 +6173,7 @@
           <p:cNvPr id="3" name="">
             <a:extLst xmlns:a="http://schemas.openxmlformats.org/drawingml/2006/main">
               <a:ext uri="{FF2B5EF4-FFF2-40B4-BE49-F238E27FC236}">
-                <a16:creationId xmlns:a16="http://schemas.microsoft.com/office/drawing/2014/main" id="{78294E09-81BB-4048-B2FD-AAFEC5E9F4CE}"/>
+                <a16:creationId xmlns:a16="http://schemas.microsoft.com/office/drawing/2014/main" id="{0C0C1DAC-293E-4478-8783-E506A8F5DF7C}"/>
               </a:ext>
             </a:extLst>
           </p:cNvPr>
@@ -6330,7 +6330,7 @@
           <p:cNvPr id="4" name="">
             <a:extLst xmlns:a="http://schemas.openxmlformats.org/drawingml/2006/main">
               <a:ext uri="{FF2B5EF4-FFF2-40B4-BE49-F238E27FC236}">
-                <a16:creationId xmlns:a16="http://schemas.microsoft.com/office/drawing/2014/main" id="{36E8E17F-85F9-43DC-9945-2EF1B5CB649D}"/>
+                <a16:creationId xmlns:a16="http://schemas.microsoft.com/office/drawing/2014/main" id="{33A5A7B4-87BE-4EF3-9CA0-EE5FABA0FE17}"/>
               </a:ext>
             </a:extLst>
           </p:cNvPr>
@@ -6487,7 +6487,7 @@
           <p:cNvPr id="5" name="">
             <a:extLst xmlns:a="http://schemas.openxmlformats.org/drawingml/2006/main">
               <a:ext uri="{FF2B5EF4-FFF2-40B4-BE49-F238E27FC236}">
-                <a16:creationId xmlns:a16="http://schemas.microsoft.com/office/drawing/2014/main" id="{0581E15C-EE78-4E7B-A672-50D2C9D8D68F}"/>
+                <a16:creationId xmlns:a16="http://schemas.microsoft.com/office/drawing/2014/main" id="{1C3861B8-4E4E-4EA8-B2B2-3239A8BF6557}"/>
               </a:ext>
             </a:extLst>
           </p:cNvPr>
@@ -6644,7 +6644,7 @@
           <p:cNvPr id="6" name="">
             <a:extLst xmlns:a="http://schemas.openxmlformats.org/drawingml/2006/main">
               <a:ext uri="{FF2B5EF4-FFF2-40B4-BE49-F238E27FC236}">
-                <a16:creationId xmlns:a16="http://schemas.microsoft.com/office/drawing/2014/main" id="{9707187F-E195-47DD-B7C5-3E812428FE79}"/>
+                <a16:creationId xmlns:a16="http://schemas.microsoft.com/office/drawing/2014/main" id="{4AADAF30-4413-456B-8721-0C01D0F553D9}"/>
               </a:ext>
             </a:extLst>
           </p:cNvPr>
@@ -6801,7 +6801,7 @@
           <p:cNvPr id="7" name="">
             <a:extLst xmlns:a="http://schemas.openxmlformats.org/drawingml/2006/main">
               <a:ext uri="{FF2B5EF4-FFF2-40B4-BE49-F238E27FC236}">
-                <a16:creationId xmlns:a16="http://schemas.microsoft.com/office/drawing/2014/main" id="{5F6BFBF3-467A-47C5-9970-DA79ACE84F1E}"/>
+                <a16:creationId xmlns:a16="http://schemas.microsoft.com/office/drawing/2014/main" id="{78A96196-041E-4754-908A-6B42794D31E7}"/>
               </a:ext>
             </a:extLst>
           </p:cNvPr>
@@ -6958,7 +6958,7 @@
           <p:cNvPr id="8" name="">
             <a:extLst xmlns:a="http://schemas.openxmlformats.org/drawingml/2006/main">
               <a:ext uri="{FF2B5EF4-FFF2-40B4-BE49-F238E27FC236}">
-                <a16:creationId xmlns:a16="http://schemas.microsoft.com/office/drawing/2014/main" id="{02A21517-3EE0-492C-B837-BB4BA7827212}"/>
+                <a16:creationId xmlns:a16="http://schemas.microsoft.com/office/drawing/2014/main" id="{CA9C6FC0-2B79-4E69-BE59-FDFC3EEB62CA}"/>
               </a:ext>
             </a:extLst>
           </p:cNvPr>
@@ -7115,7 +7115,7 @@
           <p:cNvPr id="9" name="">
             <a:extLst xmlns:a="http://schemas.openxmlformats.org/drawingml/2006/main">
               <a:ext uri="{FF2B5EF4-FFF2-40B4-BE49-F238E27FC236}">
-                <a16:creationId xmlns:a16="http://schemas.microsoft.com/office/drawing/2014/main" id="{BD58285D-EEEA-4BBB-BD37-C9EA8EA29DFB}"/>
+                <a16:creationId xmlns:a16="http://schemas.microsoft.com/office/drawing/2014/main" id="{21102F40-E2EB-48CB-952F-D9297D85C0D7}"/>
               </a:ext>
             </a:extLst>
           </p:cNvPr>
@@ -7272,7 +7272,7 @@
           <p:cNvPr id="10" name="">
             <a:extLst xmlns:a="http://schemas.openxmlformats.org/drawingml/2006/main">
               <a:ext uri="{FF2B5EF4-FFF2-40B4-BE49-F238E27FC236}">
-                <a16:creationId xmlns:a16="http://schemas.microsoft.com/office/drawing/2014/main" id="{4E8EBB8F-CB61-49E7-B95C-C72AD5209035}"/>
+                <a16:creationId xmlns:a16="http://schemas.microsoft.com/office/drawing/2014/main" id="{BA7CA16F-DD58-49A6-978F-E726838F6470}"/>
               </a:ext>
             </a:extLst>
           </p:cNvPr>
@@ -7429,7 +7429,7 @@
           <p:cNvPr id="11" name="">
             <a:extLst xmlns:a="http://schemas.openxmlformats.org/drawingml/2006/main">
               <a:ext uri="{FF2B5EF4-FFF2-40B4-BE49-F238E27FC236}">
-                <a16:creationId xmlns:a16="http://schemas.microsoft.com/office/drawing/2014/main" id="{732C61AE-1DF7-405C-BFAC-BE4CB50B3CFD}"/>
+                <a16:creationId xmlns:a16="http://schemas.microsoft.com/office/drawing/2014/main" id="{930CAFD4-2429-46D9-9CF5-2A983A5CDBFF}"/>
               </a:ext>
             </a:extLst>
           </p:cNvPr>
@@ -7584,7 +7584,7 @@
     </p:spTree>
     <p:extLst>
       <p:ext uri="{BB962C8B-B14F-4D97-AF65-F5344CB8AC3E}">
-        <p14:creationId xmlns:p14="http://schemas.microsoft.com/office/powerpoint/2010/main" val="598367774"/>
+        <p14:creationId xmlns:p14="http://schemas.microsoft.com/office/powerpoint/2010/main" val="212928731"/>
       </p:ext>
     </p:extLst>
   </p:cSld>
@@ -7615,7 +7615,7 @@
           <p:cNvPr id="12" name="">
             <a:extLst xmlns:a="http://schemas.openxmlformats.org/drawingml/2006/main">
               <a:ext uri="{FF2B5EF4-FFF2-40B4-BE49-F238E27FC236}">
-                <a16:creationId xmlns:a16="http://schemas.microsoft.com/office/drawing/2014/main" id="{6C075B76-217E-403E-B3E5-209563ADAB31}"/>
+                <a16:creationId xmlns:a16="http://schemas.microsoft.com/office/drawing/2014/main" id="{485C3A30-00E8-4E02-B7B2-964C8BF1416B}"/>
               </a:ext>
             </a:extLst>
           </p:cNvPr>
@@ -7772,7 +7772,7 @@
           <p:cNvPr id="2" name="">
             <a:extLst xmlns:a="http://schemas.openxmlformats.org/drawingml/2006/main">
               <a:ext uri="{FF2B5EF4-FFF2-40B4-BE49-F238E27FC236}">
-                <a16:creationId xmlns:a16="http://schemas.microsoft.com/office/drawing/2014/main" id="{CF88C0CF-4163-4EFB-B147-11728BA134D2}"/>
+                <a16:creationId xmlns:a16="http://schemas.microsoft.com/office/drawing/2014/main" id="{9C560C8D-3CD6-4DE2-B643-2D7D9413AAF3}"/>
               </a:ext>
             </a:extLst>
           </p:cNvPr>
@@ -7929,7 +7929,7 @@
           <p:cNvPr id="3" name="">
             <a:extLst xmlns:a="http://schemas.openxmlformats.org/drawingml/2006/main">
               <a:ext uri="{FF2B5EF4-FFF2-40B4-BE49-F238E27FC236}">
-                <a16:creationId xmlns:a16="http://schemas.microsoft.com/office/drawing/2014/main" id="{B1001DF8-6AC1-4E1A-AC9A-D494F695FCBA}"/>
+                <a16:creationId xmlns:a16="http://schemas.microsoft.com/office/drawing/2014/main" id="{072EBB6B-D726-4D8E-96F8-47E61FBA422B}"/>
               </a:ext>
             </a:extLst>
           </p:cNvPr>
@@ -8086,7 +8086,7 @@
           <p:cNvPr id="4" name="">
             <a:extLst xmlns:a="http://schemas.openxmlformats.org/drawingml/2006/main">
               <a:ext uri="{FF2B5EF4-FFF2-40B4-BE49-F238E27FC236}">
-                <a16:creationId xmlns:a16="http://schemas.microsoft.com/office/drawing/2014/main" id="{7D45E2A2-A30D-4AE4-B3EE-F189DD51DF93}"/>
+                <a16:creationId xmlns:a16="http://schemas.microsoft.com/office/drawing/2014/main" id="{AFE47C35-CD50-4BFF-BB12-A328A3B4AE6B}"/>
               </a:ext>
             </a:extLst>
           </p:cNvPr>
@@ -8243,7 +8243,7 @@
           <p:cNvPr id="5" name="">
             <a:extLst xmlns:a="http://schemas.openxmlformats.org/drawingml/2006/main">
               <a:ext uri="{FF2B5EF4-FFF2-40B4-BE49-F238E27FC236}">
-                <a16:creationId xmlns:a16="http://schemas.microsoft.com/office/drawing/2014/main" id="{157D7EC3-BA5B-4714-9533-812F45071419}"/>
+                <a16:creationId xmlns:a16="http://schemas.microsoft.com/office/drawing/2014/main" id="{735A8D58-4421-4172-A3FE-A190DE9A85DD}"/>
               </a:ext>
             </a:extLst>
           </p:cNvPr>
@@ -8400,7 +8400,7 @@
           <p:cNvPr id="6" name="">
             <a:extLst xmlns:a="http://schemas.openxmlformats.org/drawingml/2006/main">
               <a:ext uri="{FF2B5EF4-FFF2-40B4-BE49-F238E27FC236}">
-                <a16:creationId xmlns:a16="http://schemas.microsoft.com/office/drawing/2014/main" id="{D7003FDA-4B0D-4CF9-8054-324222AA2B2C}"/>
+                <a16:creationId xmlns:a16="http://schemas.microsoft.com/office/drawing/2014/main" id="{E35DF69E-4D60-4A73-914D-E84F3BB1C52F}"/>
               </a:ext>
             </a:extLst>
           </p:cNvPr>
@@ -8557,7 +8557,7 @@
           <p:cNvPr id="7" name="">
             <a:extLst xmlns:a="http://schemas.openxmlformats.org/drawingml/2006/main">
               <a:ext uri="{FF2B5EF4-FFF2-40B4-BE49-F238E27FC236}">
-                <a16:creationId xmlns:a16="http://schemas.microsoft.com/office/drawing/2014/main" id="{725EDBC6-5B1E-41BD-9187-DAE74E1B6FA7}"/>
+                <a16:creationId xmlns:a16="http://schemas.microsoft.com/office/drawing/2014/main" id="{5654D7F6-7583-436D-8A16-938156FB8E66}"/>
               </a:ext>
             </a:extLst>
           </p:cNvPr>
@@ -8714,7 +8714,7 @@
           <p:cNvPr id="8" name="">
             <a:extLst xmlns:a="http://schemas.openxmlformats.org/drawingml/2006/main">
               <a:ext uri="{FF2B5EF4-FFF2-40B4-BE49-F238E27FC236}">
-                <a16:creationId xmlns:a16="http://schemas.microsoft.com/office/drawing/2014/main" id="{E0C776F9-5577-4D37-97E5-0088CD21E8F6}"/>
+                <a16:creationId xmlns:a16="http://schemas.microsoft.com/office/drawing/2014/main" id="{483849A8-4AD4-494F-943F-46A4451CC4EB}"/>
               </a:ext>
             </a:extLst>
           </p:cNvPr>
@@ -8871,7 +8871,7 @@
           <p:cNvPr id="9" name="">
             <a:extLst xmlns:a="http://schemas.openxmlformats.org/drawingml/2006/main">
               <a:ext uri="{FF2B5EF4-FFF2-40B4-BE49-F238E27FC236}">
-                <a16:creationId xmlns:a16="http://schemas.microsoft.com/office/drawing/2014/main" id="{39E5826D-5B12-4521-AA43-9992FF7B5740}"/>
+                <a16:creationId xmlns:a16="http://schemas.microsoft.com/office/drawing/2014/main" id="{1BB2F7D0-E19D-48FA-9CFB-F1262C99B0D5}"/>
               </a:ext>
             </a:extLst>
           </p:cNvPr>
@@ -9028,7 +9028,7 @@
           <p:cNvPr id="10" name="">
             <a:extLst xmlns:a="http://schemas.openxmlformats.org/drawingml/2006/main">
               <a:ext uri="{FF2B5EF4-FFF2-40B4-BE49-F238E27FC236}">
-                <a16:creationId xmlns:a16="http://schemas.microsoft.com/office/drawing/2014/main" id="{402473B4-7B4E-4A46-8C98-B15CAADF6E8D}"/>
+                <a16:creationId xmlns:a16="http://schemas.microsoft.com/office/drawing/2014/main" id="{7EACF95E-8438-4AC7-A52A-8AF52B5F1DAC}"/>
               </a:ext>
             </a:extLst>
           </p:cNvPr>
@@ -9185,7 +9185,7 @@
           <p:cNvPr id="11" name="">
             <a:extLst xmlns:a="http://schemas.openxmlformats.org/drawingml/2006/main">
               <a:ext uri="{FF2B5EF4-FFF2-40B4-BE49-F238E27FC236}">
-                <a16:creationId xmlns:a16="http://schemas.microsoft.com/office/drawing/2014/main" id="{507CAD9D-0D99-4DBB-BF76-258B97B9413B}"/>
+                <a16:creationId xmlns:a16="http://schemas.microsoft.com/office/drawing/2014/main" id="{D5212B90-F108-4BB3-89D1-86A6865C61C4}"/>
               </a:ext>
             </a:extLst>
           </p:cNvPr>
@@ -9340,7 +9340,7 @@
     </p:spTree>
     <p:extLst>
       <p:ext uri="{BB962C8B-B14F-4D97-AF65-F5344CB8AC3E}">
-        <p14:creationId xmlns:p14="http://schemas.microsoft.com/office/powerpoint/2010/main" val="193118346"/>
+        <p14:creationId xmlns:p14="http://schemas.microsoft.com/office/powerpoint/2010/main" val="2023782813"/>
       </p:ext>
     </p:extLst>
   </p:cSld>
@@ -9371,7 +9371,7 @@
           <p:cNvPr id="9" name="">
             <a:extLst xmlns:a="http://schemas.openxmlformats.org/drawingml/2006/main">
               <a:ext uri="{FF2B5EF4-FFF2-40B4-BE49-F238E27FC236}">
-                <a16:creationId xmlns:a16="http://schemas.microsoft.com/office/drawing/2014/main" id="{8CA14577-847D-4C65-A6C9-4A64F6574F17}"/>
+                <a16:creationId xmlns:a16="http://schemas.microsoft.com/office/drawing/2014/main" id="{622E7950-3C8C-40B3-AADA-AC12689C9434}"/>
               </a:ext>
             </a:extLst>
           </p:cNvPr>
@@ -9528,7 +9528,7 @@
           <p:cNvPr id="2" name="">
             <a:extLst xmlns:a="http://schemas.openxmlformats.org/drawingml/2006/main">
               <a:ext uri="{FF2B5EF4-FFF2-40B4-BE49-F238E27FC236}">
-                <a16:creationId xmlns:a16="http://schemas.microsoft.com/office/drawing/2014/main" id="{CB2C5697-8276-458F-9658-152B93BCAEE6}"/>
+                <a16:creationId xmlns:a16="http://schemas.microsoft.com/office/drawing/2014/main" id="{A025F575-0C5E-4B70-8CAB-0D2E58C3DBC3}"/>
               </a:ext>
             </a:extLst>
           </p:cNvPr>
@@ -9685,7 +9685,7 @@
           <p:cNvPr id="3" name="">
             <a:extLst xmlns:a="http://schemas.openxmlformats.org/drawingml/2006/main">
               <a:ext uri="{FF2B5EF4-FFF2-40B4-BE49-F238E27FC236}">
-                <a16:creationId xmlns:a16="http://schemas.microsoft.com/office/drawing/2014/main" id="{2C3254C1-FA1E-4060-8096-6FA6FC186AE2}"/>
+                <a16:creationId xmlns:a16="http://schemas.microsoft.com/office/drawing/2014/main" id="{126DD460-E10C-48B9-8473-9684688EF9C0}"/>
               </a:ext>
             </a:extLst>
           </p:cNvPr>
@@ -9842,7 +9842,7 @@
           <p:cNvPr id="4" name="">
             <a:extLst xmlns:a="http://schemas.openxmlformats.org/drawingml/2006/main">
               <a:ext uri="{FF2B5EF4-FFF2-40B4-BE49-F238E27FC236}">
-                <a16:creationId xmlns:a16="http://schemas.microsoft.com/office/drawing/2014/main" id="{F70EBFAF-0674-4A01-8AC2-2843DEE13D3C}"/>
+                <a16:creationId xmlns:a16="http://schemas.microsoft.com/office/drawing/2014/main" id="{4BEA6030-DD9D-48B3-B6E1-F468B7E0DD21}"/>
               </a:ext>
             </a:extLst>
           </p:cNvPr>
@@ -9999,7 +9999,7 @@
           <p:cNvPr id="5" name="">
             <a:extLst xmlns:a="http://schemas.openxmlformats.org/drawingml/2006/main">
               <a:ext uri="{FF2B5EF4-FFF2-40B4-BE49-F238E27FC236}">
-                <a16:creationId xmlns:a16="http://schemas.microsoft.com/office/drawing/2014/main" id="{755BBF5A-5136-4B99-B502-A93C49DB2B3B}"/>
+                <a16:creationId xmlns:a16="http://schemas.microsoft.com/office/drawing/2014/main" id="{BDB4CBCF-AA72-4957-A6C7-6918BD62093E}"/>
               </a:ext>
             </a:extLst>
           </p:cNvPr>
@@ -10156,7 +10156,7 @@
           <p:cNvPr id="6" name="">
             <a:extLst xmlns:a="http://schemas.openxmlformats.org/drawingml/2006/main">
               <a:ext uri="{FF2B5EF4-FFF2-40B4-BE49-F238E27FC236}">
-                <a16:creationId xmlns:a16="http://schemas.microsoft.com/office/drawing/2014/main" id="{1EE331B7-8E85-49F3-8ED1-96EC111A0C56}"/>
+                <a16:creationId xmlns:a16="http://schemas.microsoft.com/office/drawing/2014/main" id="{E5EC0B42-3053-4332-B7ED-3FB92AED6201}"/>
               </a:ext>
             </a:extLst>
           </p:cNvPr>
@@ -10313,7 +10313,7 @@
           <p:cNvPr id="7" name="">
             <a:extLst xmlns:a="http://schemas.openxmlformats.org/drawingml/2006/main">
               <a:ext uri="{FF2B5EF4-FFF2-40B4-BE49-F238E27FC236}">
-                <a16:creationId xmlns:a16="http://schemas.microsoft.com/office/drawing/2014/main" id="{A155DA6E-50DE-485F-84A2-39AD16AC0648}"/>
+                <a16:creationId xmlns:a16="http://schemas.microsoft.com/office/drawing/2014/main" id="{5614AE9E-4254-4093-A887-3D141A2A6AC3}"/>
               </a:ext>
             </a:extLst>
           </p:cNvPr>
@@ -10470,7 +10470,7 @@
           <p:cNvPr id="8" name="">
             <a:extLst xmlns:a="http://schemas.openxmlformats.org/drawingml/2006/main">
               <a:ext uri="{FF2B5EF4-FFF2-40B4-BE49-F238E27FC236}">
-                <a16:creationId xmlns:a16="http://schemas.microsoft.com/office/drawing/2014/main" id="{ADEA1986-B050-4800-A71F-8502355E4E77}"/>
+                <a16:creationId xmlns:a16="http://schemas.microsoft.com/office/drawing/2014/main" id="{2FC4EEF8-3C70-472C-A819-088AE75C5E0B}"/>
               </a:ext>
             </a:extLst>
           </p:cNvPr>
@@ -10617,7 +10617,7 @@
                 <a:ea typeface="Arial"/>
                 <a:cs typeface="Arial"/>
               </a:rPr>
-              <a:t>Pendiente: captura de terminal, issues y revisión del compañero.</a:t>
+              <a:t>Pendiente: nueve issues y revisión del compañero.</a:t>
             </a:r>
           </a:p>
         </p:txBody>
@@ -10625,7 +10625,7 @@
     </p:spTree>
     <p:extLst>
       <p:ext uri="{BB962C8B-B14F-4D97-AF65-F5344CB8AC3E}">
-        <p14:creationId xmlns:p14="http://schemas.microsoft.com/office/powerpoint/2010/main" val="488646761"/>
+        <p14:creationId xmlns:p14="http://schemas.microsoft.com/office/powerpoint/2010/main" val="75224800"/>
       </p:ext>
     </p:extLst>
   </p:cSld>
@@ -10656,7 +10656,7 @@
           <p:cNvPr id="9" name="">
             <a:extLst xmlns:a="http://schemas.openxmlformats.org/drawingml/2006/main">
               <a:ext uri="{FF2B5EF4-FFF2-40B4-BE49-F238E27FC236}">
-                <a16:creationId xmlns:a16="http://schemas.microsoft.com/office/drawing/2014/main" id="{A79524FC-42D3-40FE-A843-605BF82F4509}"/>
+                <a16:creationId xmlns:a16="http://schemas.microsoft.com/office/drawing/2014/main" id="{8D3F16CC-3201-4EA5-837D-5601CA463CF9}"/>
               </a:ext>
             </a:extLst>
           </p:cNvPr>
@@ -10813,7 +10813,7 @@
           <p:cNvPr id="2" name="">
             <a:extLst xmlns:a="http://schemas.openxmlformats.org/drawingml/2006/main">
               <a:ext uri="{FF2B5EF4-FFF2-40B4-BE49-F238E27FC236}">
-                <a16:creationId xmlns:a16="http://schemas.microsoft.com/office/drawing/2014/main" id="{C2B397BA-DD24-4EA7-A31E-4FCE31A7CFEC}"/>
+                <a16:creationId xmlns:a16="http://schemas.microsoft.com/office/drawing/2014/main" id="{0751F5AC-54B2-4921-B66F-EC15E55373A1}"/>
               </a:ext>
             </a:extLst>
           </p:cNvPr>
@@ -10970,7 +10970,7 @@
           <p:cNvPr id="3" name="">
             <a:extLst xmlns:a="http://schemas.openxmlformats.org/drawingml/2006/main">
               <a:ext uri="{FF2B5EF4-FFF2-40B4-BE49-F238E27FC236}">
-                <a16:creationId xmlns:a16="http://schemas.microsoft.com/office/drawing/2014/main" id="{EF1CCEAF-8D01-414D-953B-06A7421468C9}"/>
+                <a16:creationId xmlns:a16="http://schemas.microsoft.com/office/drawing/2014/main" id="{D66F9D8B-A242-44FD-93DC-7891824D8B78}"/>
               </a:ext>
             </a:extLst>
           </p:cNvPr>
@@ -11127,7 +11127,7 @@
           <p:cNvPr id="4" name="">
             <a:extLst xmlns:a="http://schemas.openxmlformats.org/drawingml/2006/main">
               <a:ext uri="{FF2B5EF4-FFF2-40B4-BE49-F238E27FC236}">
-                <a16:creationId xmlns:a16="http://schemas.microsoft.com/office/drawing/2014/main" id="{2C97BA74-B99A-4FAF-AA88-16C39C77D7F8}"/>
+                <a16:creationId xmlns:a16="http://schemas.microsoft.com/office/drawing/2014/main" id="{929BE775-B40B-4D10-8626-0E3AFD358306}"/>
               </a:ext>
             </a:extLst>
           </p:cNvPr>
@@ -11284,7 +11284,7 @@
           <p:cNvPr id="5" name="">
             <a:extLst xmlns:a="http://schemas.openxmlformats.org/drawingml/2006/main">
               <a:ext uri="{FF2B5EF4-FFF2-40B4-BE49-F238E27FC236}">
-                <a16:creationId xmlns:a16="http://schemas.microsoft.com/office/drawing/2014/main" id="{062E600D-68D9-40F7-9479-6C996B68BF7E}"/>
+                <a16:creationId xmlns:a16="http://schemas.microsoft.com/office/drawing/2014/main" id="{A778C735-C042-46B9-BF7E-5969141F8842}"/>
               </a:ext>
             </a:extLst>
           </p:cNvPr>
@@ -11441,7 +11441,7 @@
           <p:cNvPr id="6" name="">
             <a:extLst xmlns:a="http://schemas.openxmlformats.org/drawingml/2006/main">
               <a:ext uri="{FF2B5EF4-FFF2-40B4-BE49-F238E27FC236}">
-                <a16:creationId xmlns:a16="http://schemas.microsoft.com/office/drawing/2014/main" id="{87CA5327-4959-444B-AF63-1F08B8E6B96E}"/>
+                <a16:creationId xmlns:a16="http://schemas.microsoft.com/office/drawing/2014/main" id="{7DFA1A4A-4445-4E8D-98E8-1817CC2D83BF}"/>
               </a:ext>
             </a:extLst>
           </p:cNvPr>
@@ -11598,7 +11598,7 @@
           <p:cNvPr id="7" name="">
             <a:extLst xmlns:a="http://schemas.openxmlformats.org/drawingml/2006/main">
               <a:ext uri="{FF2B5EF4-FFF2-40B4-BE49-F238E27FC236}">
-                <a16:creationId xmlns:a16="http://schemas.microsoft.com/office/drawing/2014/main" id="{4EB72FFD-36FA-42BF-B910-3FF6AD28E962}"/>
+                <a16:creationId xmlns:a16="http://schemas.microsoft.com/office/drawing/2014/main" id="{A69C6407-6D82-4374-9B04-810F9F68363E}"/>
               </a:ext>
             </a:extLst>
           </p:cNvPr>
@@ -11755,7 +11755,7 @@
           <p:cNvPr id="8" name="">
             <a:extLst xmlns:a="http://schemas.openxmlformats.org/drawingml/2006/main">
               <a:ext uri="{FF2B5EF4-FFF2-40B4-BE49-F238E27FC236}">
-                <a16:creationId xmlns:a16="http://schemas.microsoft.com/office/drawing/2014/main" id="{8F28C3F7-8F1F-40BF-A9F4-9758448B9CA7}"/>
+                <a16:creationId xmlns:a16="http://schemas.microsoft.com/office/drawing/2014/main" id="{F8C3A0EB-84D2-4791-9B57-D129CB67D5F8}"/>
               </a:ext>
             </a:extLst>
           </p:cNvPr>
@@ -11910,7 +11910,7 @@
     </p:spTree>
     <p:extLst>
       <p:ext uri="{BB962C8B-B14F-4D97-AF65-F5344CB8AC3E}">
-        <p14:creationId xmlns:p14="http://schemas.microsoft.com/office/powerpoint/2010/main" val="1761873006"/>
+        <p14:creationId xmlns:p14="http://schemas.microsoft.com/office/powerpoint/2010/main" val="294527897"/>
       </p:ext>
     </p:extLst>
   </p:cSld>
@@ -11941,7 +11941,7 @@
           <p:cNvPr id="9" name="">
             <a:extLst xmlns:a="http://schemas.openxmlformats.org/drawingml/2006/main">
               <a:ext uri="{FF2B5EF4-FFF2-40B4-BE49-F238E27FC236}">
-                <a16:creationId xmlns:a16="http://schemas.microsoft.com/office/drawing/2014/main" id="{BA1A5331-8B46-42CF-81CF-FD6FE22709F4}"/>
+                <a16:creationId xmlns:a16="http://schemas.microsoft.com/office/drawing/2014/main" id="{E78FB1A3-CD62-434F-AE43-20977EE0C3DF}"/>
               </a:ext>
             </a:extLst>
           </p:cNvPr>
@@ -12098,7 +12098,7 @@
           <p:cNvPr id="2" name="">
             <a:extLst xmlns:a="http://schemas.openxmlformats.org/drawingml/2006/main">
               <a:ext uri="{FF2B5EF4-FFF2-40B4-BE49-F238E27FC236}">
-                <a16:creationId xmlns:a16="http://schemas.microsoft.com/office/drawing/2014/main" id="{A63B3A3E-B0AA-45E8-95DE-7843288FB235}"/>
+                <a16:creationId xmlns:a16="http://schemas.microsoft.com/office/drawing/2014/main" id="{2E352E5D-0C40-4AA4-8C97-3F3F0858F2B2}"/>
               </a:ext>
             </a:extLst>
           </p:cNvPr>
@@ -12255,7 +12255,7 @@
           <p:cNvPr id="3" name="">
             <a:extLst xmlns:a="http://schemas.openxmlformats.org/drawingml/2006/main">
               <a:ext uri="{FF2B5EF4-FFF2-40B4-BE49-F238E27FC236}">
-                <a16:creationId xmlns:a16="http://schemas.microsoft.com/office/drawing/2014/main" id="{5BAFAC5D-F432-4D5D-9E30-F335D1A743EA}"/>
+                <a16:creationId xmlns:a16="http://schemas.microsoft.com/office/drawing/2014/main" id="{B8024FC9-BF49-425E-9947-94064922275B}"/>
               </a:ext>
             </a:extLst>
           </p:cNvPr>
@@ -12412,7 +12412,7 @@
           <p:cNvPr id="4" name="">
             <a:extLst xmlns:a="http://schemas.openxmlformats.org/drawingml/2006/main">
               <a:ext uri="{FF2B5EF4-FFF2-40B4-BE49-F238E27FC236}">
-                <a16:creationId xmlns:a16="http://schemas.microsoft.com/office/drawing/2014/main" id="{F6A2D188-0DB6-4754-A0A3-D83589F669D6}"/>
+                <a16:creationId xmlns:a16="http://schemas.microsoft.com/office/drawing/2014/main" id="{9DB56C82-5907-4733-A5C6-7F1726E0F101}"/>
               </a:ext>
             </a:extLst>
           </p:cNvPr>
@@ -12569,7 +12569,7 @@
           <p:cNvPr id="5" name="">
             <a:extLst xmlns:a="http://schemas.openxmlformats.org/drawingml/2006/main">
               <a:ext uri="{FF2B5EF4-FFF2-40B4-BE49-F238E27FC236}">
-                <a16:creationId xmlns:a16="http://schemas.microsoft.com/office/drawing/2014/main" id="{BAECA54D-0CC7-4EE1-AE2C-D03BEFA37923}"/>
+                <a16:creationId xmlns:a16="http://schemas.microsoft.com/office/drawing/2014/main" id="{E1B38753-03DE-4E93-A326-C5A4FDF1E63F}"/>
               </a:ext>
             </a:extLst>
           </p:cNvPr>
@@ -12726,7 +12726,7 @@
           <p:cNvPr id="6" name="">
             <a:extLst xmlns:a="http://schemas.openxmlformats.org/drawingml/2006/main">
               <a:ext uri="{FF2B5EF4-FFF2-40B4-BE49-F238E27FC236}">
-                <a16:creationId xmlns:a16="http://schemas.microsoft.com/office/drawing/2014/main" id="{49419D94-B6F3-4057-BDBF-D4A9E7436225}"/>
+                <a16:creationId xmlns:a16="http://schemas.microsoft.com/office/drawing/2014/main" id="{94F0FA90-19C7-4E25-82C8-9B470B337CF3}"/>
               </a:ext>
             </a:extLst>
           </p:cNvPr>
@@ -12883,7 +12883,7 @@
           <p:cNvPr id="7" name="">
             <a:extLst xmlns:a="http://schemas.openxmlformats.org/drawingml/2006/main">
               <a:ext uri="{FF2B5EF4-FFF2-40B4-BE49-F238E27FC236}">
-                <a16:creationId xmlns:a16="http://schemas.microsoft.com/office/drawing/2014/main" id="{B3928A9A-9151-4A9F-8EC6-A62F907EBAB3}"/>
+                <a16:creationId xmlns:a16="http://schemas.microsoft.com/office/drawing/2014/main" id="{8124A639-BC35-442E-B233-F53CF7CEE59E}"/>
               </a:ext>
             </a:extLst>
           </p:cNvPr>
@@ -13040,7 +13040,7 @@
           <p:cNvPr id="8" name="">
             <a:extLst xmlns:a="http://schemas.openxmlformats.org/drawingml/2006/main">
               <a:ext uri="{FF2B5EF4-FFF2-40B4-BE49-F238E27FC236}">
-                <a16:creationId xmlns:a16="http://schemas.microsoft.com/office/drawing/2014/main" id="{F7AB073A-A9AB-4E24-9747-1F654E4BE435}"/>
+                <a16:creationId xmlns:a16="http://schemas.microsoft.com/office/drawing/2014/main" id="{544317D8-CA87-4D95-8231-24C42E8E00FF}"/>
               </a:ext>
             </a:extLst>
           </p:cNvPr>
@@ -13195,7 +13195,7 @@
     </p:spTree>
     <p:extLst>
       <p:ext uri="{BB962C8B-B14F-4D97-AF65-F5344CB8AC3E}">
-        <p14:creationId xmlns:p14="http://schemas.microsoft.com/office/powerpoint/2010/main" val="437329699"/>
+        <p14:creationId xmlns:p14="http://schemas.microsoft.com/office/powerpoint/2010/main" val="451267424"/>
       </p:ext>
     </p:extLst>
   </p:cSld>
@@ -13226,7 +13226,7 @@
           <p:cNvPr id="7" name="">
             <a:extLst xmlns:a="http://schemas.openxmlformats.org/drawingml/2006/main">
               <a:ext uri="{FF2B5EF4-FFF2-40B4-BE49-F238E27FC236}">
-                <a16:creationId xmlns:a16="http://schemas.microsoft.com/office/drawing/2014/main" id="{026F518B-469C-4A30-B025-8BD0132F0B60}"/>
+                <a16:creationId xmlns:a16="http://schemas.microsoft.com/office/drawing/2014/main" id="{214FBB21-518C-46D5-8954-A1565DB62E51}"/>
               </a:ext>
             </a:extLst>
           </p:cNvPr>
@@ -13383,7 +13383,7 @@
           <p:cNvPr id="2" name="">
             <a:extLst xmlns:a="http://schemas.openxmlformats.org/drawingml/2006/main">
               <a:ext uri="{FF2B5EF4-FFF2-40B4-BE49-F238E27FC236}">
-                <a16:creationId xmlns:a16="http://schemas.microsoft.com/office/drawing/2014/main" id="{1D9D507E-C0B0-453E-B884-F2A358645358}"/>
+                <a16:creationId xmlns:a16="http://schemas.microsoft.com/office/drawing/2014/main" id="{90415400-F0E0-44A1-9692-C88CFAC1706E}"/>
               </a:ext>
             </a:extLst>
           </p:cNvPr>
@@ -13540,7 +13540,7 @@
           <p:cNvPr id="3" name="">
             <a:extLst xmlns:a="http://schemas.openxmlformats.org/drawingml/2006/main">
               <a:ext uri="{FF2B5EF4-FFF2-40B4-BE49-F238E27FC236}">
-                <a16:creationId xmlns:a16="http://schemas.microsoft.com/office/drawing/2014/main" id="{6BC26CBA-C909-4977-AFEF-CB849412BD13}"/>
+                <a16:creationId xmlns:a16="http://schemas.microsoft.com/office/drawing/2014/main" id="{FE379BAA-4660-4314-8E20-E813F895288D}"/>
               </a:ext>
             </a:extLst>
           </p:cNvPr>
@@ -13697,7 +13697,7 @@
           <p:cNvPr id="4" name="">
             <a:extLst xmlns:a="http://schemas.openxmlformats.org/drawingml/2006/main">
               <a:ext uri="{FF2B5EF4-FFF2-40B4-BE49-F238E27FC236}">
-                <a16:creationId xmlns:a16="http://schemas.microsoft.com/office/drawing/2014/main" id="{1C2C49FF-56ED-480D-9E63-B62911EC4468}"/>
+                <a16:creationId xmlns:a16="http://schemas.microsoft.com/office/drawing/2014/main" id="{745BA6F6-1682-4B5D-9231-1234A4EC8AAC}"/>
               </a:ext>
             </a:extLst>
           </p:cNvPr>
@@ -13854,7 +13854,7 @@
           <p:cNvPr id="5" name="">
             <a:extLst xmlns:a="http://schemas.openxmlformats.org/drawingml/2006/main">
               <a:ext uri="{FF2B5EF4-FFF2-40B4-BE49-F238E27FC236}">
-                <a16:creationId xmlns:a16="http://schemas.microsoft.com/office/drawing/2014/main" id="{B137B431-FFC9-4C6C-A15D-47B0A64CB9E1}"/>
+                <a16:creationId xmlns:a16="http://schemas.microsoft.com/office/drawing/2014/main" id="{3E25C218-3DFF-4070-A585-453EF7B7F683}"/>
               </a:ext>
             </a:extLst>
           </p:cNvPr>
@@ -14011,7 +14011,7 @@
           <p:cNvPr id="6" name="">
             <a:extLst xmlns:a="http://schemas.openxmlformats.org/drawingml/2006/main">
               <a:ext uri="{FF2B5EF4-FFF2-40B4-BE49-F238E27FC236}">
-                <a16:creationId xmlns:a16="http://schemas.microsoft.com/office/drawing/2014/main" id="{A7D4F58F-68B6-46C2-98E9-EDFC39181BFA}"/>
+                <a16:creationId xmlns:a16="http://schemas.microsoft.com/office/drawing/2014/main" id="{2C9E7A40-51B8-4A03-AD48-0FD06E6238D8}"/>
               </a:ext>
             </a:extLst>
           </p:cNvPr>
@@ -14021,7 +14021,7 @@
           <p:nvPr/>
         </p:nvPicPr>
         <p:blipFill>
-          <a:blip xmlns:r="http://schemas.openxmlformats.org/officeDocument/2006/relationships" xmlns:a="http://schemas.openxmlformats.org/drawingml/2006/main" r:embed="R5a24866ceb1943a6"/>
+          <a:blip xmlns:r="http://schemas.openxmlformats.org/officeDocument/2006/relationships" xmlns:a="http://schemas.openxmlformats.org/drawingml/2006/main" r:embed="Rb3397aeb68604f87"/>
           <a:stretch xmlns:a="http://schemas.openxmlformats.org/drawingml/2006/main"/>
         </p:blipFill>
         <p:spPr>
@@ -14037,7 +14037,7 @@
     </p:spTree>
     <p:extLst>
       <p:ext uri="{BB962C8B-B14F-4D97-AF65-F5344CB8AC3E}">
-        <p14:creationId xmlns:p14="http://schemas.microsoft.com/office/powerpoint/2010/main" val="2082113821"/>
+        <p14:creationId xmlns:p14="http://schemas.microsoft.com/office/powerpoint/2010/main" val="625599579"/>
       </p:ext>
     </p:extLst>
   </p:cSld>
@@ -14068,7 +14068,7 @@
           <p:cNvPr id="7" name="">
             <a:extLst xmlns:a="http://schemas.openxmlformats.org/drawingml/2006/main">
               <a:ext uri="{FF2B5EF4-FFF2-40B4-BE49-F238E27FC236}">
-                <a16:creationId xmlns:a16="http://schemas.microsoft.com/office/drawing/2014/main" id="{64AC9C25-30B1-4B5E-8E39-BBADB7C91319}"/>
+                <a16:creationId xmlns:a16="http://schemas.microsoft.com/office/drawing/2014/main" id="{93DB2E5D-A526-4622-A35D-1936C7AD9862}"/>
               </a:ext>
             </a:extLst>
           </p:cNvPr>
@@ -14225,7 +14225,7 @@
           <p:cNvPr id="2" name="">
             <a:extLst xmlns:a="http://schemas.openxmlformats.org/drawingml/2006/main">
               <a:ext uri="{FF2B5EF4-FFF2-40B4-BE49-F238E27FC236}">
-                <a16:creationId xmlns:a16="http://schemas.microsoft.com/office/drawing/2014/main" id="{71D745F0-83FE-49D0-910B-8DF8E0310AEC}"/>
+                <a16:creationId xmlns:a16="http://schemas.microsoft.com/office/drawing/2014/main" id="{ADAE5D2E-25FF-4476-99EC-382BC95385AF}"/>
               </a:ext>
             </a:extLst>
           </p:cNvPr>
@@ -14382,7 +14382,7 @@
           <p:cNvPr id="3" name="">
             <a:extLst xmlns:a="http://schemas.openxmlformats.org/drawingml/2006/main">
               <a:ext uri="{FF2B5EF4-FFF2-40B4-BE49-F238E27FC236}">
-                <a16:creationId xmlns:a16="http://schemas.microsoft.com/office/drawing/2014/main" id="{1A5CBBF1-E1B0-417B-8D01-9323ACD8E1E3}"/>
+                <a16:creationId xmlns:a16="http://schemas.microsoft.com/office/drawing/2014/main" id="{75C8C1F4-6E9D-4E62-AC92-79D8F6E30C96}"/>
               </a:ext>
             </a:extLst>
           </p:cNvPr>
@@ -14539,7 +14539,7 @@
           <p:cNvPr id="4" name="">
             <a:extLst xmlns:a="http://schemas.openxmlformats.org/drawingml/2006/main">
               <a:ext uri="{FF2B5EF4-FFF2-40B4-BE49-F238E27FC236}">
-                <a16:creationId xmlns:a16="http://schemas.microsoft.com/office/drawing/2014/main" id="{8908D3D5-583D-40B1-879B-2C9899C329C2}"/>
+                <a16:creationId xmlns:a16="http://schemas.microsoft.com/office/drawing/2014/main" id="{B9C03DB5-4660-4501-8DC1-4C9371A0C9F2}"/>
               </a:ext>
             </a:extLst>
           </p:cNvPr>
@@ -14696,7 +14696,7 @@
           <p:cNvPr id="5" name="">
             <a:extLst xmlns:a="http://schemas.openxmlformats.org/drawingml/2006/main">
               <a:ext uri="{FF2B5EF4-FFF2-40B4-BE49-F238E27FC236}">
-                <a16:creationId xmlns:a16="http://schemas.microsoft.com/office/drawing/2014/main" id="{2E9E79B0-6F36-49DE-B2A1-E145FC7F2008}"/>
+                <a16:creationId xmlns:a16="http://schemas.microsoft.com/office/drawing/2014/main" id="{F3B64796-28E1-4DC7-B045-C25F6119B930}"/>
               </a:ext>
             </a:extLst>
           </p:cNvPr>
@@ -14853,7 +14853,7 @@
           <p:cNvPr id="6" name="">
             <a:extLst xmlns:a="http://schemas.openxmlformats.org/drawingml/2006/main">
               <a:ext uri="{FF2B5EF4-FFF2-40B4-BE49-F238E27FC236}">
-                <a16:creationId xmlns:a16="http://schemas.microsoft.com/office/drawing/2014/main" id="{282B5DA6-9B74-47C2-9DCF-DC4F253FB2E2}"/>
+                <a16:creationId xmlns:a16="http://schemas.microsoft.com/office/drawing/2014/main" id="{05F02711-92C4-4336-AAB5-CE87AFE3AEAA}"/>
               </a:ext>
             </a:extLst>
           </p:cNvPr>
@@ -14863,7 +14863,7 @@
           <p:nvPr/>
         </p:nvPicPr>
         <p:blipFill>
-          <a:blip xmlns:r="http://schemas.openxmlformats.org/officeDocument/2006/relationships" xmlns:a="http://schemas.openxmlformats.org/drawingml/2006/main" r:embed="R2574242b18b446a0"/>
+          <a:blip xmlns:r="http://schemas.openxmlformats.org/officeDocument/2006/relationships" xmlns:a="http://schemas.openxmlformats.org/drawingml/2006/main" r:embed="Rc50ff65b72c4461c"/>
           <a:stretch xmlns:a="http://schemas.openxmlformats.org/drawingml/2006/main"/>
         </p:blipFill>
         <p:spPr>
@@ -14879,7 +14879,7 @@
     </p:spTree>
     <p:extLst>
       <p:ext uri="{BB962C8B-B14F-4D97-AF65-F5344CB8AC3E}">
-        <p14:creationId xmlns:p14="http://schemas.microsoft.com/office/powerpoint/2010/main" val="93500615"/>
+        <p14:creationId xmlns:p14="http://schemas.microsoft.com/office/powerpoint/2010/main" val="354166101"/>
       </p:ext>
     </p:extLst>
   </p:cSld>
@@ -14910,7 +14910,7 @@
           <p:cNvPr id="7" name="">
             <a:extLst xmlns:a="http://schemas.openxmlformats.org/drawingml/2006/main">
               <a:ext uri="{FF2B5EF4-FFF2-40B4-BE49-F238E27FC236}">
-                <a16:creationId xmlns:a16="http://schemas.microsoft.com/office/drawing/2014/main" id="{DF296F56-A3BA-48FA-B4AB-7D6E5EE0F3ED}"/>
+                <a16:creationId xmlns:a16="http://schemas.microsoft.com/office/drawing/2014/main" id="{A18FEAB7-A4AE-427F-89B5-C2EFD0B1215C}"/>
               </a:ext>
             </a:extLst>
           </p:cNvPr>
@@ -15067,7 +15067,7 @@
           <p:cNvPr id="2" name="">
             <a:extLst xmlns:a="http://schemas.openxmlformats.org/drawingml/2006/main">
               <a:ext uri="{FF2B5EF4-FFF2-40B4-BE49-F238E27FC236}">
-                <a16:creationId xmlns:a16="http://schemas.microsoft.com/office/drawing/2014/main" id="{096D19B4-744E-4FA6-834C-3DAD10236A88}"/>
+                <a16:creationId xmlns:a16="http://schemas.microsoft.com/office/drawing/2014/main" id="{C6219B22-A1C0-4DA0-A1BC-B1E134C574DC}"/>
               </a:ext>
             </a:extLst>
           </p:cNvPr>
@@ -15224,7 +15224,7 @@
           <p:cNvPr id="3" name="">
             <a:extLst xmlns:a="http://schemas.openxmlformats.org/drawingml/2006/main">
               <a:ext uri="{FF2B5EF4-FFF2-40B4-BE49-F238E27FC236}">
-                <a16:creationId xmlns:a16="http://schemas.microsoft.com/office/drawing/2014/main" id="{D2C4C059-22C6-446C-ACDC-2AFC61237E3A}"/>
+                <a16:creationId xmlns:a16="http://schemas.microsoft.com/office/drawing/2014/main" id="{B64FF62F-59A0-4BDB-BD25-C9469898083F}"/>
               </a:ext>
             </a:extLst>
           </p:cNvPr>
@@ -15381,7 +15381,7 @@
           <p:cNvPr id="4" name="">
             <a:extLst xmlns:a="http://schemas.openxmlformats.org/drawingml/2006/main">
               <a:ext uri="{FF2B5EF4-FFF2-40B4-BE49-F238E27FC236}">
-                <a16:creationId xmlns:a16="http://schemas.microsoft.com/office/drawing/2014/main" id="{634651A2-4965-47BC-AB4C-4B4897E4E050}"/>
+                <a16:creationId xmlns:a16="http://schemas.microsoft.com/office/drawing/2014/main" id="{496D242B-09FC-4387-9C15-5C5DD51A20D3}"/>
               </a:ext>
             </a:extLst>
           </p:cNvPr>
@@ -15538,7 +15538,7 @@
           <p:cNvPr id="5" name="">
             <a:extLst xmlns:a="http://schemas.openxmlformats.org/drawingml/2006/main">
               <a:ext uri="{FF2B5EF4-FFF2-40B4-BE49-F238E27FC236}">
-                <a16:creationId xmlns:a16="http://schemas.microsoft.com/office/drawing/2014/main" id="{A3502600-09AF-42A6-881A-0747A2B02831}"/>
+                <a16:creationId xmlns:a16="http://schemas.microsoft.com/office/drawing/2014/main" id="{624F6B33-A14D-4375-9B02-1A4D5F3C6870}"/>
               </a:ext>
             </a:extLst>
           </p:cNvPr>
@@ -15695,7 +15695,7 @@
           <p:cNvPr id="6" name="">
             <a:extLst xmlns:a="http://schemas.openxmlformats.org/drawingml/2006/main">
               <a:ext uri="{FF2B5EF4-FFF2-40B4-BE49-F238E27FC236}">
-                <a16:creationId xmlns:a16="http://schemas.microsoft.com/office/drawing/2014/main" id="{7E6EFFF6-D56B-4C8B-AC41-CEF18A9182BC}"/>
+                <a16:creationId xmlns:a16="http://schemas.microsoft.com/office/drawing/2014/main" id="{5ED74110-1774-405B-B268-3BC5E4EBEDC2}"/>
               </a:ext>
             </a:extLst>
           </p:cNvPr>
@@ -15705,7 +15705,7 @@
           <p:nvPr/>
         </p:nvPicPr>
         <p:blipFill>
-          <a:blip xmlns:r="http://schemas.openxmlformats.org/officeDocument/2006/relationships" xmlns:a="http://schemas.openxmlformats.org/drawingml/2006/main" r:embed="R644a51b89d754f84"/>
+          <a:blip xmlns:r="http://schemas.openxmlformats.org/officeDocument/2006/relationships" xmlns:a="http://schemas.openxmlformats.org/drawingml/2006/main" r:embed="R47f21ab833fa4768"/>
           <a:stretch xmlns:a="http://schemas.openxmlformats.org/drawingml/2006/main"/>
         </p:blipFill>
         <p:spPr>
@@ -15721,7 +15721,7 @@
     </p:spTree>
     <p:extLst>
       <p:ext uri="{BB962C8B-B14F-4D97-AF65-F5344CB8AC3E}">
-        <p14:creationId xmlns:p14="http://schemas.microsoft.com/office/powerpoint/2010/main" val="768328360"/>
+        <p14:creationId xmlns:p14="http://schemas.microsoft.com/office/powerpoint/2010/main" val="1980205195"/>
       </p:ext>
     </p:extLst>
   </p:cSld>
@@ -15752,7 +15752,7 @@
           <p:cNvPr id="7" name="">
             <a:extLst xmlns:a="http://schemas.openxmlformats.org/drawingml/2006/main">
               <a:ext uri="{FF2B5EF4-FFF2-40B4-BE49-F238E27FC236}">
-                <a16:creationId xmlns:a16="http://schemas.microsoft.com/office/drawing/2014/main" id="{6B095437-FCF0-4083-BABA-52D802727D45}"/>
+                <a16:creationId xmlns:a16="http://schemas.microsoft.com/office/drawing/2014/main" id="{043AAB30-C42F-49FA-A0AF-32800200AE79}"/>
               </a:ext>
             </a:extLst>
           </p:cNvPr>
@@ -15909,7 +15909,7 @@
           <p:cNvPr id="2" name="">
             <a:extLst xmlns:a="http://schemas.openxmlformats.org/drawingml/2006/main">
               <a:ext uri="{FF2B5EF4-FFF2-40B4-BE49-F238E27FC236}">
-                <a16:creationId xmlns:a16="http://schemas.microsoft.com/office/drawing/2014/main" id="{86492EFA-800F-4E4A-8FD7-AADA75AAE0AC}"/>
+                <a16:creationId xmlns:a16="http://schemas.microsoft.com/office/drawing/2014/main" id="{C293074B-D90D-485E-9040-9414EC8E3431}"/>
               </a:ext>
             </a:extLst>
           </p:cNvPr>
@@ -16066,7 +16066,7 @@
           <p:cNvPr id="3" name="">
             <a:extLst xmlns:a="http://schemas.openxmlformats.org/drawingml/2006/main">
               <a:ext uri="{FF2B5EF4-FFF2-40B4-BE49-F238E27FC236}">
-                <a16:creationId xmlns:a16="http://schemas.microsoft.com/office/drawing/2014/main" id="{692E6FA6-DDF5-4CFD-A0DF-777983C483CE}"/>
+                <a16:creationId xmlns:a16="http://schemas.microsoft.com/office/drawing/2014/main" id="{6F697ADF-8450-478D-9A3E-C5E29391B329}"/>
               </a:ext>
             </a:extLst>
           </p:cNvPr>
@@ -16223,7 +16223,7 @@
           <p:cNvPr id="4" name="">
             <a:extLst xmlns:a="http://schemas.openxmlformats.org/drawingml/2006/main">
               <a:ext uri="{FF2B5EF4-FFF2-40B4-BE49-F238E27FC236}">
-                <a16:creationId xmlns:a16="http://schemas.microsoft.com/office/drawing/2014/main" id="{92BC3166-DB61-48D6-B8D3-2ABC51462D67}"/>
+                <a16:creationId xmlns:a16="http://schemas.microsoft.com/office/drawing/2014/main" id="{8AE3429B-8B91-46F4-8441-063008CF23D0}"/>
               </a:ext>
             </a:extLst>
           </p:cNvPr>
@@ -16380,7 +16380,7 @@
           <p:cNvPr id="5" name="">
             <a:extLst xmlns:a="http://schemas.openxmlformats.org/drawingml/2006/main">
               <a:ext uri="{FF2B5EF4-FFF2-40B4-BE49-F238E27FC236}">
-                <a16:creationId xmlns:a16="http://schemas.microsoft.com/office/drawing/2014/main" id="{696F1E84-5128-4A93-A424-BF7A097C4A1A}"/>
+                <a16:creationId xmlns:a16="http://schemas.microsoft.com/office/drawing/2014/main" id="{9EDD5720-EA4D-441B-9E4C-80AF5A0A31D8}"/>
               </a:ext>
             </a:extLst>
           </p:cNvPr>
@@ -16537,7 +16537,7 @@
           <p:cNvPr id="6" name="">
             <a:extLst xmlns:a="http://schemas.openxmlformats.org/drawingml/2006/main">
               <a:ext uri="{FF2B5EF4-FFF2-40B4-BE49-F238E27FC236}">
-                <a16:creationId xmlns:a16="http://schemas.microsoft.com/office/drawing/2014/main" id="{624C30F3-2A27-461C-923E-22507D0C34F8}"/>
+                <a16:creationId xmlns:a16="http://schemas.microsoft.com/office/drawing/2014/main" id="{EC8358A8-469B-4F44-9B62-7838B316575F}"/>
               </a:ext>
             </a:extLst>
           </p:cNvPr>
@@ -17278,7 +17278,7 @@
     </p:spTree>
     <p:extLst>
       <p:ext uri="{BB962C8B-B14F-4D97-AF65-F5344CB8AC3E}">
-        <p14:creationId xmlns:p14="http://schemas.microsoft.com/office/powerpoint/2010/main" val="41138772"/>
+        <p14:creationId xmlns:p14="http://schemas.microsoft.com/office/powerpoint/2010/main" val="1881660197"/>
       </p:ext>
     </p:extLst>
   </p:cSld>
@@ -17309,7 +17309,7 @@
           <p:cNvPr id="12" name="">
             <a:extLst xmlns:a="http://schemas.openxmlformats.org/drawingml/2006/main">
               <a:ext uri="{FF2B5EF4-FFF2-40B4-BE49-F238E27FC236}">
-                <a16:creationId xmlns:a16="http://schemas.microsoft.com/office/drawing/2014/main" id="{D6C2F182-E450-4474-BB7E-377C5D6F0E00}"/>
+                <a16:creationId xmlns:a16="http://schemas.microsoft.com/office/drawing/2014/main" id="{6070EC37-1C9F-43E2-92A1-0DD1B2C1AA91}"/>
               </a:ext>
             </a:extLst>
           </p:cNvPr>
@@ -17466,7 +17466,7 @@
           <p:cNvPr id="2" name="">
             <a:extLst xmlns:a="http://schemas.openxmlformats.org/drawingml/2006/main">
               <a:ext uri="{FF2B5EF4-FFF2-40B4-BE49-F238E27FC236}">
-                <a16:creationId xmlns:a16="http://schemas.microsoft.com/office/drawing/2014/main" id="{6329BB4A-58EE-4842-A963-4FFD3C72AAE3}"/>
+                <a16:creationId xmlns:a16="http://schemas.microsoft.com/office/drawing/2014/main" id="{62F3C8D7-F98A-45F8-8345-3B8C688AA8E1}"/>
               </a:ext>
             </a:extLst>
           </p:cNvPr>
@@ -17623,7 +17623,7 @@
           <p:cNvPr id="3" name="">
             <a:extLst xmlns:a="http://schemas.openxmlformats.org/drawingml/2006/main">
               <a:ext uri="{FF2B5EF4-FFF2-40B4-BE49-F238E27FC236}">
-                <a16:creationId xmlns:a16="http://schemas.microsoft.com/office/drawing/2014/main" id="{31FCD7D4-46F1-40C1-BCDB-2505703C5D1F}"/>
+                <a16:creationId xmlns:a16="http://schemas.microsoft.com/office/drawing/2014/main" id="{E144876C-2D78-4CB4-BE05-978E688D05C5}"/>
               </a:ext>
             </a:extLst>
           </p:cNvPr>
@@ -17780,7 +17780,7 @@
           <p:cNvPr id="4" name="">
             <a:extLst xmlns:a="http://schemas.openxmlformats.org/drawingml/2006/main">
               <a:ext uri="{FF2B5EF4-FFF2-40B4-BE49-F238E27FC236}">
-                <a16:creationId xmlns:a16="http://schemas.microsoft.com/office/drawing/2014/main" id="{37AC77E1-88D7-4694-9126-D2A980D521B6}"/>
+                <a16:creationId xmlns:a16="http://schemas.microsoft.com/office/drawing/2014/main" id="{EE2A9F43-4E16-4412-A375-1F7D75060806}"/>
               </a:ext>
             </a:extLst>
           </p:cNvPr>
@@ -17937,7 +17937,7 @@
           <p:cNvPr id="5" name="">
             <a:extLst xmlns:a="http://schemas.openxmlformats.org/drawingml/2006/main">
               <a:ext uri="{FF2B5EF4-FFF2-40B4-BE49-F238E27FC236}">
-                <a16:creationId xmlns:a16="http://schemas.microsoft.com/office/drawing/2014/main" id="{1A0C3E09-4CE9-4BD4-9128-EADDE755A029}"/>
+                <a16:creationId xmlns:a16="http://schemas.microsoft.com/office/drawing/2014/main" id="{6C77294A-5AF9-414F-9B7F-A21E01249125}"/>
               </a:ext>
             </a:extLst>
           </p:cNvPr>
@@ -18094,7 +18094,7 @@
           <p:cNvPr id="6" name="">
             <a:extLst xmlns:a="http://schemas.openxmlformats.org/drawingml/2006/main">
               <a:ext uri="{FF2B5EF4-FFF2-40B4-BE49-F238E27FC236}">
-                <a16:creationId xmlns:a16="http://schemas.microsoft.com/office/drawing/2014/main" id="{4C680773-1ACB-4831-A4DA-5E6C9767291E}"/>
+                <a16:creationId xmlns:a16="http://schemas.microsoft.com/office/drawing/2014/main" id="{E3C2201B-69E0-47FE-95F0-21754FFC5904}"/>
               </a:ext>
             </a:extLst>
           </p:cNvPr>
@@ -18251,7 +18251,7 @@
           <p:cNvPr id="7" name="">
             <a:extLst xmlns:a="http://schemas.openxmlformats.org/drawingml/2006/main">
               <a:ext uri="{FF2B5EF4-FFF2-40B4-BE49-F238E27FC236}">
-                <a16:creationId xmlns:a16="http://schemas.microsoft.com/office/drawing/2014/main" id="{549D2364-D2DE-4E35-85A7-60AAABE10D04}"/>
+                <a16:creationId xmlns:a16="http://schemas.microsoft.com/office/drawing/2014/main" id="{B6CDF267-1B19-4080-B891-14474AFBEB92}"/>
               </a:ext>
             </a:extLst>
           </p:cNvPr>
@@ -18408,7 +18408,7 @@
           <p:cNvPr id="8" name="">
             <a:extLst xmlns:a="http://schemas.openxmlformats.org/drawingml/2006/main">
               <a:ext uri="{FF2B5EF4-FFF2-40B4-BE49-F238E27FC236}">
-                <a16:creationId xmlns:a16="http://schemas.microsoft.com/office/drawing/2014/main" id="{8E9619A5-AB6C-497E-8D1A-BDF28869ABD5}"/>
+                <a16:creationId xmlns:a16="http://schemas.microsoft.com/office/drawing/2014/main" id="{061F9E10-00BC-4B31-A7BA-B83A43A58025}"/>
               </a:ext>
             </a:extLst>
           </p:cNvPr>
@@ -18565,7 +18565,7 @@
           <p:cNvPr id="9" name="">
             <a:extLst xmlns:a="http://schemas.openxmlformats.org/drawingml/2006/main">
               <a:ext uri="{FF2B5EF4-FFF2-40B4-BE49-F238E27FC236}">
-                <a16:creationId xmlns:a16="http://schemas.microsoft.com/office/drawing/2014/main" id="{BAD92A6C-086E-41F5-953E-62689C927707}"/>
+                <a16:creationId xmlns:a16="http://schemas.microsoft.com/office/drawing/2014/main" id="{0692F9AA-598D-4ECE-A498-53E9D928A3D2}"/>
               </a:ext>
             </a:extLst>
           </p:cNvPr>
@@ -18722,7 +18722,7 @@
           <p:cNvPr id="10" name="">
             <a:extLst xmlns:a="http://schemas.openxmlformats.org/drawingml/2006/main">
               <a:ext uri="{FF2B5EF4-FFF2-40B4-BE49-F238E27FC236}">
-                <a16:creationId xmlns:a16="http://schemas.microsoft.com/office/drawing/2014/main" id="{474D6C2F-4AC2-4D6C-A0C9-1B02D0EC51CD}"/>
+                <a16:creationId xmlns:a16="http://schemas.microsoft.com/office/drawing/2014/main" id="{F5924A9A-69C0-49A0-B013-13D75380A0FE}"/>
               </a:ext>
             </a:extLst>
           </p:cNvPr>
@@ -18879,7 +18879,7 @@
           <p:cNvPr id="11" name="">
             <a:extLst xmlns:a="http://schemas.openxmlformats.org/drawingml/2006/main">
               <a:ext uri="{FF2B5EF4-FFF2-40B4-BE49-F238E27FC236}">
-                <a16:creationId xmlns:a16="http://schemas.microsoft.com/office/drawing/2014/main" id="{F6AB7DB6-5947-4D99-A179-9F83E89EAE26}"/>
+                <a16:creationId xmlns:a16="http://schemas.microsoft.com/office/drawing/2014/main" id="{E90ED4B3-01F3-4CB6-B7FE-9DFC0DE078B8}"/>
               </a:ext>
             </a:extLst>
           </p:cNvPr>
@@ -19034,7 +19034,7 @@
     </p:spTree>
     <p:extLst>
       <p:ext uri="{BB962C8B-B14F-4D97-AF65-F5344CB8AC3E}">
-        <p14:creationId xmlns:p14="http://schemas.microsoft.com/office/powerpoint/2010/main" val="1100884955"/>
+        <p14:creationId xmlns:p14="http://schemas.microsoft.com/office/powerpoint/2010/main" val="1516532919"/>
       </p:ext>
     </p:extLst>
   </p:cSld>
@@ -19065,7 +19065,7 @@
           <p:cNvPr id="12" name="">
             <a:extLst xmlns:a="http://schemas.openxmlformats.org/drawingml/2006/main">
               <a:ext uri="{FF2B5EF4-FFF2-40B4-BE49-F238E27FC236}">
-                <a16:creationId xmlns:a16="http://schemas.microsoft.com/office/drawing/2014/main" id="{97C400CA-68C7-4ECA-AA42-6E44F573B701}"/>
+                <a16:creationId xmlns:a16="http://schemas.microsoft.com/office/drawing/2014/main" id="{F5AF7A41-432D-4893-A6D3-E627A72A7CDE}"/>
               </a:ext>
             </a:extLst>
           </p:cNvPr>
@@ -19222,7 +19222,7 @@
           <p:cNvPr id="2" name="">
             <a:extLst xmlns:a="http://schemas.openxmlformats.org/drawingml/2006/main">
               <a:ext uri="{FF2B5EF4-FFF2-40B4-BE49-F238E27FC236}">
-                <a16:creationId xmlns:a16="http://schemas.microsoft.com/office/drawing/2014/main" id="{F3BBC5A2-261D-4C9E-B206-D505752CD43A}"/>
+                <a16:creationId xmlns:a16="http://schemas.microsoft.com/office/drawing/2014/main" id="{7227B503-2285-4818-8761-C2F2AEC123ED}"/>
               </a:ext>
             </a:extLst>
           </p:cNvPr>
@@ -19379,7 +19379,7 @@
           <p:cNvPr id="3" name="">
             <a:extLst xmlns:a="http://schemas.openxmlformats.org/drawingml/2006/main">
               <a:ext uri="{FF2B5EF4-FFF2-40B4-BE49-F238E27FC236}">
-                <a16:creationId xmlns:a16="http://schemas.microsoft.com/office/drawing/2014/main" id="{DAA4862D-F13E-4225-B488-0DACFD499A56}"/>
+                <a16:creationId xmlns:a16="http://schemas.microsoft.com/office/drawing/2014/main" id="{A55B4672-69AD-4CEF-95C0-6560B68AAB7F}"/>
               </a:ext>
             </a:extLst>
           </p:cNvPr>
@@ -19536,7 +19536,7 @@
           <p:cNvPr id="4" name="">
             <a:extLst xmlns:a="http://schemas.openxmlformats.org/drawingml/2006/main">
               <a:ext uri="{FF2B5EF4-FFF2-40B4-BE49-F238E27FC236}">
-                <a16:creationId xmlns:a16="http://schemas.microsoft.com/office/drawing/2014/main" id="{0B9E5E8D-619B-49C7-BE7A-50BFE6A9FA59}"/>
+                <a16:creationId xmlns:a16="http://schemas.microsoft.com/office/drawing/2014/main" id="{8D69CE75-993E-4201-B686-D4754B99DB08}"/>
               </a:ext>
             </a:extLst>
           </p:cNvPr>
@@ -19693,7 +19693,7 @@
           <p:cNvPr id="5" name="">
             <a:extLst xmlns:a="http://schemas.openxmlformats.org/drawingml/2006/main">
               <a:ext uri="{FF2B5EF4-FFF2-40B4-BE49-F238E27FC236}">
-                <a16:creationId xmlns:a16="http://schemas.microsoft.com/office/drawing/2014/main" id="{73DBEA5A-E701-4C2D-9017-41B1E8A61DD1}"/>
+                <a16:creationId xmlns:a16="http://schemas.microsoft.com/office/drawing/2014/main" id="{2BE1CE6B-0086-494B-BCF5-15C1D87E8F90}"/>
               </a:ext>
             </a:extLst>
           </p:cNvPr>
@@ -19850,7 +19850,7 @@
           <p:cNvPr id="6" name="">
             <a:extLst xmlns:a="http://schemas.openxmlformats.org/drawingml/2006/main">
               <a:ext uri="{FF2B5EF4-FFF2-40B4-BE49-F238E27FC236}">
-                <a16:creationId xmlns:a16="http://schemas.microsoft.com/office/drawing/2014/main" id="{15D1264C-68CE-4B9B-99EA-C168A35E7543}"/>
+                <a16:creationId xmlns:a16="http://schemas.microsoft.com/office/drawing/2014/main" id="{76407D9F-7CEF-40F9-B4AE-063196EDD701}"/>
               </a:ext>
             </a:extLst>
           </p:cNvPr>
@@ -20007,7 +20007,7 @@
           <p:cNvPr id="7" name="">
             <a:extLst xmlns:a="http://schemas.openxmlformats.org/drawingml/2006/main">
               <a:ext uri="{FF2B5EF4-FFF2-40B4-BE49-F238E27FC236}">
-                <a16:creationId xmlns:a16="http://schemas.microsoft.com/office/drawing/2014/main" id="{782107A0-B36D-461C-BAC4-389A75441218}"/>
+                <a16:creationId xmlns:a16="http://schemas.microsoft.com/office/drawing/2014/main" id="{F8886837-A913-4F4D-8585-9DC2949C6E5B}"/>
               </a:ext>
             </a:extLst>
           </p:cNvPr>
@@ -20164,7 +20164,7 @@
           <p:cNvPr id="8" name="">
             <a:extLst xmlns:a="http://schemas.openxmlformats.org/drawingml/2006/main">
               <a:ext uri="{FF2B5EF4-FFF2-40B4-BE49-F238E27FC236}">
-                <a16:creationId xmlns:a16="http://schemas.microsoft.com/office/drawing/2014/main" id="{32F5A017-0C4F-4738-B1B6-999D2A876C4B}"/>
+                <a16:creationId xmlns:a16="http://schemas.microsoft.com/office/drawing/2014/main" id="{992B7017-9DC0-4018-8729-8099410D9A3E}"/>
               </a:ext>
             </a:extLst>
           </p:cNvPr>
@@ -20321,7 +20321,7 @@
           <p:cNvPr id="9" name="">
             <a:extLst xmlns:a="http://schemas.openxmlformats.org/drawingml/2006/main">
               <a:ext uri="{FF2B5EF4-FFF2-40B4-BE49-F238E27FC236}">
-                <a16:creationId xmlns:a16="http://schemas.microsoft.com/office/drawing/2014/main" id="{8C3A2D34-DD1C-42E4-BACC-F988060105BA}"/>
+                <a16:creationId xmlns:a16="http://schemas.microsoft.com/office/drawing/2014/main" id="{20B43142-C7D0-4B50-9FD7-608916708951}"/>
               </a:ext>
             </a:extLst>
           </p:cNvPr>
@@ -20478,7 +20478,7 @@
           <p:cNvPr id="10" name="">
             <a:extLst xmlns:a="http://schemas.openxmlformats.org/drawingml/2006/main">
               <a:ext uri="{FF2B5EF4-FFF2-40B4-BE49-F238E27FC236}">
-                <a16:creationId xmlns:a16="http://schemas.microsoft.com/office/drawing/2014/main" id="{33BB3391-5104-43D9-B028-89A03BB94087}"/>
+                <a16:creationId xmlns:a16="http://schemas.microsoft.com/office/drawing/2014/main" id="{9985C195-8881-4D1C-8E52-ACDDE7F468D3}"/>
               </a:ext>
             </a:extLst>
           </p:cNvPr>
@@ -20635,7 +20635,7 @@
           <p:cNvPr id="11" name="">
             <a:extLst xmlns:a="http://schemas.openxmlformats.org/drawingml/2006/main">
               <a:ext uri="{FF2B5EF4-FFF2-40B4-BE49-F238E27FC236}">
-                <a16:creationId xmlns:a16="http://schemas.microsoft.com/office/drawing/2014/main" id="{FDD3F078-93D3-413A-A689-0DE53598ECDF}"/>
+                <a16:creationId xmlns:a16="http://schemas.microsoft.com/office/drawing/2014/main" id="{1CCB075D-2977-4BF8-8EAD-3716B9194241}"/>
               </a:ext>
             </a:extLst>
           </p:cNvPr>
@@ -20790,7 +20790,7 @@
     </p:spTree>
     <p:extLst>
       <p:ext uri="{BB962C8B-B14F-4D97-AF65-F5344CB8AC3E}">
-        <p14:creationId xmlns:p14="http://schemas.microsoft.com/office/powerpoint/2010/main" val="1839313499"/>
+        <p14:creationId xmlns:p14="http://schemas.microsoft.com/office/powerpoint/2010/main" val="994286881"/>
       </p:ext>
     </p:extLst>
   </p:cSld>

</xml_diff>